<commit_message>
Consistency polish: matching monograms, divider page numbers, symmetric bridge slide
Co-Authored-By: Claude Fable 5 <noreply@anthropic.com>
</commit_message>
<xml_diff>
--- a/decks/build-your-own-donna-v2.pptx
+++ b/decks/build-your-own-donna-v2.pptx
@@ -6488,7 +6488,46 @@
       </p:sp>
       <p:sp>
         <p:nvSpPr>
-          <p:cNvPr id="8" name="Shape 6"/>
+          <p:cNvPr id="8" name="Text 6"/>
+          <p:cNvSpPr/>
+          <p:nvPr/>
+        </p:nvSpPr>
+        <p:spPr>
+          <a:xfrm>
+            <a:off x="10652760" y="5943600"/>
+            <a:ext cx="731520" cy="182880"/>
+          </a:xfrm>
+          <a:prstGeom prst="rect">
+            <a:avLst/>
+          </a:prstGeom>
+          <a:noFill/>
+          <a:ln/>
+        </p:spPr>
+        <p:txBody>
+          <a:bodyPr wrap="square" lIns="0" tIns="0" rIns="0" bIns="0" rtlCol="0" anchor="ctr"/>
+          <a:lstStyle/>
+          <a:p>
+            <a:pPr algn="r" indent="0" marL="0">
+              <a:buNone/>
+            </a:pPr>
+            <a:r>
+              <a:rPr lang="en-US" sz="900" spc="120" kern="0" dirty="0">
+                <a:solidFill>
+                  <a:srgbClr val="AFA893"/>
+                </a:solidFill>
+                <a:latin typeface="Arial" pitchFamily="34" charset="0"/>
+                <a:ea typeface="Arial" pitchFamily="34" charset="-122"/>
+                <a:cs typeface="Arial" pitchFamily="34" charset="-120"/>
+              </a:rPr>
+              <a:t>11</a:t>
+            </a:r>
+            <a:endParaRPr lang="en-US" sz="900" dirty="0"/>
+          </a:p>
+        </p:txBody>
+      </p:sp>
+      <p:sp>
+        <p:nvSpPr>
+          <p:cNvPr id="9" name="Shape 7"/>
           <p:cNvSpPr/>
           <p:nvPr/>
         </p:nvSpPr>
@@ -6510,7 +6549,7 @@
       </p:sp>
       <p:sp>
         <p:nvSpPr>
-          <p:cNvPr id="9" name="Shape 7"/>
+          <p:cNvPr id="10" name="Shape 8"/>
           <p:cNvSpPr/>
           <p:nvPr/>
         </p:nvSpPr>
@@ -6535,7 +6574,7 @@
       </p:sp>
       <p:sp>
         <p:nvSpPr>
-          <p:cNvPr id="10" name="Shape 8"/>
+          <p:cNvPr id="11" name="Shape 9"/>
           <p:cNvSpPr/>
           <p:nvPr/>
         </p:nvSpPr>
@@ -6560,7 +6599,7 @@
       </p:sp>
       <p:sp>
         <p:nvSpPr>
-          <p:cNvPr id="11" name="Shape 9"/>
+          <p:cNvPr id="12" name="Shape 10"/>
           <p:cNvSpPr/>
           <p:nvPr/>
         </p:nvSpPr>
@@ -6585,7 +6624,7 @@
       </p:sp>
       <p:sp>
         <p:nvSpPr>
-          <p:cNvPr id="12" name="Shape 10"/>
+          <p:cNvPr id="13" name="Shape 11"/>
           <p:cNvSpPr/>
           <p:nvPr/>
         </p:nvSpPr>
@@ -6610,7 +6649,7 @@
       </p:sp>
       <p:sp>
         <p:nvSpPr>
-          <p:cNvPr id="13" name="Text 11"/>
+          <p:cNvPr id="14" name="Text 12"/>
           <p:cNvSpPr/>
           <p:nvPr/>
         </p:nvSpPr>
@@ -6649,7 +6688,7 @@
       </p:sp>
       <p:sp>
         <p:nvSpPr>
-          <p:cNvPr id="14" name="Text 12"/>
+          <p:cNvPr id="15" name="Text 13"/>
           <p:cNvSpPr/>
           <p:nvPr/>
         </p:nvSpPr>
@@ -6688,7 +6727,7 @@
       </p:sp>
       <p:sp>
         <p:nvSpPr>
-          <p:cNvPr id="15" name="Text 13"/>
+          <p:cNvPr id="16" name="Text 14"/>
           <p:cNvSpPr/>
           <p:nvPr/>
         </p:nvSpPr>
@@ -6727,7 +6766,7 @@
       </p:sp>
       <p:sp>
         <p:nvSpPr>
-          <p:cNvPr id="16" name="Text 14"/>
+          <p:cNvPr id="17" name="Text 15"/>
           <p:cNvSpPr/>
           <p:nvPr/>
         </p:nvSpPr>
@@ -8797,7 +8836,46 @@
       </p:sp>
       <p:sp>
         <p:nvSpPr>
-          <p:cNvPr id="8" name="Shape 6"/>
+          <p:cNvPr id="8" name="Text 6"/>
+          <p:cNvSpPr/>
+          <p:nvPr/>
+        </p:nvSpPr>
+        <p:spPr>
+          <a:xfrm>
+            <a:off x="10652760" y="5943600"/>
+            <a:ext cx="731520" cy="182880"/>
+          </a:xfrm>
+          <a:prstGeom prst="rect">
+            <a:avLst/>
+          </a:prstGeom>
+          <a:noFill/>
+          <a:ln/>
+        </p:spPr>
+        <p:txBody>
+          <a:bodyPr wrap="square" lIns="0" tIns="0" rIns="0" bIns="0" rtlCol="0" anchor="ctr"/>
+          <a:lstStyle/>
+          <a:p>
+            <a:pPr algn="r" indent="0" marL="0">
+              <a:buNone/>
+            </a:pPr>
+            <a:r>
+              <a:rPr lang="en-US" sz="900" spc="120" kern="0" dirty="0">
+                <a:solidFill>
+                  <a:srgbClr val="AFA893"/>
+                </a:solidFill>
+                <a:latin typeface="Arial" pitchFamily="34" charset="0"/>
+                <a:ea typeface="Arial" pitchFamily="34" charset="-122"/>
+                <a:cs typeface="Arial" pitchFamily="34" charset="-120"/>
+              </a:rPr>
+              <a:t>14</a:t>
+            </a:r>
+            <a:endParaRPr lang="en-US" sz="900" dirty="0"/>
+          </a:p>
+        </p:txBody>
+      </p:sp>
+      <p:sp>
+        <p:nvSpPr>
+          <p:cNvPr id="9" name="Shape 7"/>
           <p:cNvSpPr/>
           <p:nvPr/>
         </p:nvSpPr>
@@ -8819,7 +8897,7 @@
       </p:sp>
       <p:sp>
         <p:nvSpPr>
-          <p:cNvPr id="9" name="Shape 7"/>
+          <p:cNvPr id="10" name="Shape 8"/>
           <p:cNvSpPr/>
           <p:nvPr/>
         </p:nvSpPr>
@@ -8844,7 +8922,7 @@
       </p:sp>
       <p:sp>
         <p:nvSpPr>
-          <p:cNvPr id="10" name="Shape 8"/>
+          <p:cNvPr id="11" name="Shape 9"/>
           <p:cNvSpPr/>
           <p:nvPr/>
         </p:nvSpPr>
@@ -8869,7 +8947,7 @@
       </p:sp>
       <p:sp>
         <p:nvSpPr>
-          <p:cNvPr id="11" name="Shape 9"/>
+          <p:cNvPr id="12" name="Shape 10"/>
           <p:cNvSpPr/>
           <p:nvPr/>
         </p:nvSpPr>
@@ -8894,7 +8972,7 @@
       </p:sp>
       <p:sp>
         <p:nvSpPr>
-          <p:cNvPr id="12" name="Shape 10"/>
+          <p:cNvPr id="13" name="Shape 11"/>
           <p:cNvSpPr/>
           <p:nvPr/>
         </p:nvSpPr>
@@ -8919,7 +8997,7 @@
       </p:sp>
       <p:sp>
         <p:nvSpPr>
-          <p:cNvPr id="13" name="Text 11"/>
+          <p:cNvPr id="14" name="Text 12"/>
           <p:cNvSpPr/>
           <p:nvPr/>
         </p:nvSpPr>
@@ -8958,7 +9036,7 @@
       </p:sp>
       <p:sp>
         <p:nvSpPr>
-          <p:cNvPr id="14" name="Text 12"/>
+          <p:cNvPr id="15" name="Text 13"/>
           <p:cNvSpPr/>
           <p:nvPr/>
         </p:nvSpPr>
@@ -8997,7 +9075,7 @@
       </p:sp>
       <p:sp>
         <p:nvSpPr>
-          <p:cNvPr id="15" name="Text 13"/>
+          <p:cNvPr id="16" name="Text 14"/>
           <p:cNvSpPr/>
           <p:nvPr/>
         </p:nvSpPr>
@@ -9036,7 +9114,7 @@
       </p:sp>
       <p:sp>
         <p:nvSpPr>
-          <p:cNvPr id="16" name="Text 14"/>
+          <p:cNvPr id="17" name="Text 15"/>
           <p:cNvSpPr/>
           <p:nvPr/>
         </p:nvSpPr>
@@ -11332,7 +11410,46 @@
       </p:sp>
       <p:sp>
         <p:nvSpPr>
-          <p:cNvPr id="8" name="Shape 6"/>
+          <p:cNvPr id="8" name="Text 6"/>
+          <p:cNvSpPr/>
+          <p:nvPr/>
+        </p:nvSpPr>
+        <p:spPr>
+          <a:xfrm>
+            <a:off x="10652760" y="5943600"/>
+            <a:ext cx="731520" cy="182880"/>
+          </a:xfrm>
+          <a:prstGeom prst="rect">
+            <a:avLst/>
+          </a:prstGeom>
+          <a:noFill/>
+          <a:ln/>
+        </p:spPr>
+        <p:txBody>
+          <a:bodyPr wrap="square" lIns="0" tIns="0" rIns="0" bIns="0" rtlCol="0" anchor="ctr"/>
+          <a:lstStyle/>
+          <a:p>
+            <a:pPr algn="r" indent="0" marL="0">
+              <a:buNone/>
+            </a:pPr>
+            <a:r>
+              <a:rPr lang="en-US" sz="900" spc="120" kern="0" dirty="0">
+                <a:solidFill>
+                  <a:srgbClr val="AFA893"/>
+                </a:solidFill>
+                <a:latin typeface="Arial" pitchFamily="34" charset="0"/>
+                <a:ea typeface="Arial" pitchFamily="34" charset="-122"/>
+                <a:cs typeface="Arial" pitchFamily="34" charset="-120"/>
+              </a:rPr>
+              <a:t>17</a:t>
+            </a:r>
+            <a:endParaRPr lang="en-US" sz="900" dirty="0"/>
+          </a:p>
+        </p:txBody>
+      </p:sp>
+      <p:sp>
+        <p:nvSpPr>
+          <p:cNvPr id="9" name="Shape 7"/>
           <p:cNvSpPr/>
           <p:nvPr/>
         </p:nvSpPr>
@@ -11354,7 +11471,7 @@
       </p:sp>
       <p:sp>
         <p:nvSpPr>
-          <p:cNvPr id="9" name="Shape 7"/>
+          <p:cNvPr id="10" name="Shape 8"/>
           <p:cNvSpPr/>
           <p:nvPr/>
         </p:nvSpPr>
@@ -11379,7 +11496,7 @@
       </p:sp>
       <p:sp>
         <p:nvSpPr>
-          <p:cNvPr id="10" name="Shape 8"/>
+          <p:cNvPr id="11" name="Shape 9"/>
           <p:cNvSpPr/>
           <p:nvPr/>
         </p:nvSpPr>
@@ -11404,7 +11521,7 @@
       </p:sp>
       <p:sp>
         <p:nvSpPr>
-          <p:cNvPr id="11" name="Shape 9"/>
+          <p:cNvPr id="12" name="Shape 10"/>
           <p:cNvSpPr/>
           <p:nvPr/>
         </p:nvSpPr>
@@ -11429,7 +11546,7 @@
       </p:sp>
       <p:sp>
         <p:nvSpPr>
-          <p:cNvPr id="12" name="Shape 10"/>
+          <p:cNvPr id="13" name="Shape 11"/>
           <p:cNvSpPr/>
           <p:nvPr/>
         </p:nvSpPr>
@@ -11454,7 +11571,7 @@
       </p:sp>
       <p:sp>
         <p:nvSpPr>
-          <p:cNvPr id="13" name="Text 11"/>
+          <p:cNvPr id="14" name="Text 12"/>
           <p:cNvSpPr/>
           <p:nvPr/>
         </p:nvSpPr>
@@ -11493,7 +11610,7 @@
       </p:sp>
       <p:sp>
         <p:nvSpPr>
-          <p:cNvPr id="14" name="Text 12"/>
+          <p:cNvPr id="15" name="Text 13"/>
           <p:cNvSpPr/>
           <p:nvPr/>
         </p:nvSpPr>
@@ -11532,7 +11649,7 @@
       </p:sp>
       <p:sp>
         <p:nvSpPr>
-          <p:cNvPr id="15" name="Text 13"/>
+          <p:cNvPr id="16" name="Text 14"/>
           <p:cNvSpPr/>
           <p:nvPr/>
         </p:nvSpPr>
@@ -11571,7 +11688,7 @@
       </p:sp>
       <p:sp>
         <p:nvSpPr>
-          <p:cNvPr id="16" name="Text 14"/>
+          <p:cNvPr id="17" name="Text 15"/>
           <p:cNvSpPr/>
           <p:nvPr/>
         </p:nvSpPr>
@@ -13806,7 +13923,7 @@
               <a:buNone/>
             </a:pPr>
             <a:r>
-              <a:rPr lang="en-US" sz="800" b="1" spc="40" kern="0" dirty="0">
+              <a:rPr lang="en-US" sz="900" b="1" spc="60" kern="0" dirty="0">
                 <a:solidFill>
                   <a:srgbClr val="5A6379"/>
                 </a:solidFill>
@@ -13814,9 +13931,9 @@
                 <a:ea typeface="Arial" pitchFamily="34" charset="-122"/>
                 <a:cs typeface="Arial" pitchFamily="34" charset="-120"/>
               </a:rPr>
-              <a:t>MORE BOOKINGS · MORE DATA · MORE PERSONAL TRIPS</a:t>
-            </a:r>
-            <a:endParaRPr lang="en-US" sz="800" dirty="0"/>
+              <a:t>BOOKINGS · DATA · PERSONAL TRIPS · BOOKINGS</a:t>
+            </a:r>
+            <a:endParaRPr lang="en-US" sz="900" dirty="0"/>
           </a:p>
         </p:txBody>
       </p:sp>
@@ -13828,8 +13945,8 @@
         </p:nvSpPr>
         <p:spPr>
           <a:xfrm>
-            <a:off x="6903720" y="4718304"/>
-            <a:ext cx="4480560" cy="219456"/>
+            <a:off x="6675120" y="4718304"/>
+            <a:ext cx="4937760" cy="219456"/>
           </a:xfrm>
           <a:prstGeom prst="rect">
             <a:avLst/>
@@ -13845,15 +13962,15 @@
               <a:buNone/>
             </a:pPr>
             <a:r>
-              <a:rPr lang="en-US" sz="900" b="1" spc="80" kern="0" dirty="0">
-                <a:solidFill>
-                  <a:srgbClr val="8A6D14"/>
-                </a:solidFill>
-                <a:latin typeface="Arial" pitchFamily="34" charset="0"/>
-                <a:ea typeface="Arial" pitchFamily="34" charset="-122"/>
-                <a:cs typeface="Arial" pitchFamily="34" charset="-120"/>
-              </a:rPr>
-              <a:t>DOCUMENT  ·  TEST  ·  REVISE  ·  OPERATE</a:t>
+              <a:rPr lang="en-US" sz="900" b="1" spc="60" kern="0" dirty="0">
+                <a:solidFill>
+                  <a:srgbClr val="5A6379"/>
+                </a:solidFill>
+                <a:latin typeface="Arial" pitchFamily="34" charset="0"/>
+                <a:ea typeface="Arial" pitchFamily="34" charset="-122"/>
+                <a:cs typeface="Arial" pitchFamily="34" charset="-120"/>
+              </a:rPr>
+              <a:t>DOCUMENT · TEST · REVISE · OPERATE</a:t>
             </a:r>
             <a:endParaRPr lang="en-US" sz="900" dirty="0"/>
           </a:p>
@@ -13886,7 +14003,7 @@
             <a:r>
               <a:rPr lang="en-US" sz="1200" b="1" spc="160" kern="0" dirty="0">
                 <a:solidFill>
-                  <a:srgbClr val="5A6379"/>
+                  <a:srgbClr val="8A6D14"/>
                 </a:solidFill>
                 <a:latin typeface="Arial" pitchFamily="34" charset="0"/>
                 <a:ea typeface="Arial" pitchFamily="34" charset="-122"/>
@@ -19973,8 +20090,8 @@
         </p:nvSpPr>
         <p:spPr>
           <a:xfrm>
-            <a:off x="5501945" y="795528"/>
-            <a:ext cx="1188720" cy="1188720"/>
+            <a:off x="5392217" y="722376"/>
+            <a:ext cx="1408176" cy="1408176"/>
           </a:xfrm>
           <a:prstGeom prst="ellipse">
             <a:avLst/>
@@ -19995,8 +20112,8 @@
         </p:nvSpPr>
         <p:spPr>
           <a:xfrm>
-            <a:off x="5589910" y="883493"/>
-            <a:ext cx="1012789" cy="1012789"/>
+            <a:off x="5496422" y="826581"/>
+            <a:ext cx="1199766" cy="1199766"/>
           </a:xfrm>
           <a:prstGeom prst="ellipse">
             <a:avLst/>
@@ -20017,8 +20134,8 @@
         </p:nvSpPr>
         <p:spPr>
           <a:xfrm>
-            <a:off x="6096305" y="765810"/>
-            <a:ext cx="0" cy="59436"/>
+            <a:off x="6096305" y="687172"/>
+            <a:ext cx="0" cy="70409"/>
           </a:xfrm>
           <a:prstGeom prst="line">
             <a:avLst/>
@@ -20040,8 +20157,8 @@
         </p:nvSpPr>
         <p:spPr>
           <a:xfrm>
-            <a:off x="6096305" y="1954530"/>
-            <a:ext cx="0" cy="59436"/>
+            <a:off x="6096305" y="2095348"/>
+            <a:ext cx="0" cy="70409"/>
           </a:xfrm>
           <a:prstGeom prst="line">
             <a:avLst/>
@@ -20063,8 +20180,8 @@
         </p:nvSpPr>
         <p:spPr>
           <a:xfrm>
-            <a:off x="5472227" y="1389888"/>
-            <a:ext cx="59436" cy="0"/>
+            <a:off x="5357012" y="1426464"/>
+            <a:ext cx="70409" cy="0"/>
           </a:xfrm>
           <a:prstGeom prst="line">
             <a:avLst/>
@@ -20086,8 +20203,8 @@
         </p:nvSpPr>
         <p:spPr>
           <a:xfrm>
-            <a:off x="6660947" y="1389888"/>
-            <a:ext cx="59436" cy="0"/>
+            <a:off x="6765188" y="1426464"/>
+            <a:ext cx="70409" cy="0"/>
           </a:xfrm>
           <a:prstGeom prst="line">
             <a:avLst/>
@@ -20109,8 +20226,8 @@
         </p:nvSpPr>
         <p:spPr>
           <a:xfrm>
-            <a:off x="5589910" y="883493"/>
-            <a:ext cx="1012789" cy="1012789"/>
+            <a:off x="5496422" y="826581"/>
+            <a:ext cx="1199766" cy="1199766"/>
           </a:xfrm>
           <a:prstGeom prst="rect">
             <a:avLst/>
@@ -20126,7 +20243,7 @@
               <a:buNone/>
             </a:pPr>
             <a:r>
-              <a:rPr lang="en-US" sz="4700" b="1" dirty="0">
+              <a:rPr lang="en-US" sz="5500" b="1" dirty="0">
                 <a:solidFill>
                   <a:srgbClr val="A31621"/>
                 </a:solidFill>
@@ -20136,7 +20253,7 @@
               </a:rPr>
               <a:t>D</a:t>
             </a:r>
-            <a:endParaRPr lang="en-US" sz="4700" dirty="0"/>
+            <a:endParaRPr lang="en-US" sz="5500" dirty="0"/>
           </a:p>
         </p:txBody>
       </p:sp>
@@ -20148,7 +20265,7 @@
         </p:nvSpPr>
         <p:spPr>
           <a:xfrm>
-            <a:off x="1706728" y="2231136"/>
+            <a:off x="1706728" y="2304288"/>
             <a:ext cx="8778240" cy="1667134"/>
           </a:xfrm>
           <a:prstGeom prst="rect">
@@ -20168,7 +20285,7 @@
         </p:nvSpPr>
         <p:spPr>
           <a:xfrm>
-            <a:off x="2163928" y="2487168"/>
+            <a:off x="2163928" y="2560320"/>
             <a:ext cx="7863840" cy="880750"/>
           </a:xfrm>
           <a:prstGeom prst="rect">
@@ -20207,7 +20324,7 @@
         </p:nvSpPr>
         <p:spPr>
           <a:xfrm>
-            <a:off x="2163928" y="3495934"/>
+            <a:off x="2163928" y="3569086"/>
             <a:ext cx="7863840" cy="219456"/>
           </a:xfrm>
           <a:prstGeom prst="rect">
@@ -20246,7 +20363,7 @@
         </p:nvSpPr>
         <p:spPr>
           <a:xfrm>
-            <a:off x="813816" y="4209166"/>
+            <a:off x="813816" y="4282318"/>
             <a:ext cx="10570464" cy="658368"/>
           </a:xfrm>
           <a:prstGeom prst="rect">
@@ -20285,7 +20402,7 @@
         </p:nvSpPr>
         <p:spPr>
           <a:xfrm>
-            <a:off x="813816" y="4958974"/>
+            <a:off x="813816" y="5032126"/>
             <a:ext cx="10570464" cy="256032"/>
           </a:xfrm>
           <a:prstGeom prst="rect">

</xml_diff>